<commit_message>
feat: implement storage service with Supabase integration and category management modules
</commit_message>
<xml_diff>
--- a/Resultados_Alling_X1-X5.pptx
+++ b/Resultados_Alling_X1-X5.pptx
@@ -12,6 +12,7 @@
     <p:sldId id="257" r:id="rId5"/>
     <p:sldId id="258" r:id="rId6"/>
     <p:sldId id="259" r:id="rId7"/>
+    <p:sldId id="260" r:id="rId8"/>
   </p:sldIdLst>
   <p:sldSz cx="12192000" cy="6858000"/>
   <p:notesSz cx="6858000" cy="12192000"/>
@@ -4010,6 +4011,359 @@
               <a:t>Plataforma B2B Alling  ·  Ayacucho, 2026</a:t>
             </a:r>
             <a:endParaRPr lang="en-US" sz="1100" dirty="0"/>
+          </a:p>
+        </p:txBody>
+      </p:sp>
+    </p:spTree>
+  </p:cSld>
+  <p:clrMapOvr>
+    <a:masterClrMapping/>
+  </p:clrMapOvr>
+</p:sld>
+</file>
+
+<file path=ppt/slides/slide5.xml><?xml version="1.0" encoding="utf-8"?>
+<p:sld xmlns:a="http://schemas.openxmlformats.org/drawingml/2006/main" xmlns:r="http://schemas.openxmlformats.org/officeDocument/2006/relationships" xmlns:p="http://schemas.openxmlformats.org/presentationml/2006/main">
+  <p:cSld>
+    <p:spTree>
+      <p:nvGrpSpPr>
+        <p:cNvPr id="1" name=""/>
+        <p:cNvGrpSpPr/>
+        <p:nvPr/>
+      </p:nvGrpSpPr>
+      <p:grpSpPr/>
+      <p:sp>
+        <p:nvSpPr>
+          <p:cNvPr id="2" name="Cuadro de texto 1"/>
+          <p:cNvSpPr txBox="1"/>
+          <p:nvPr/>
+        </p:nvSpPr>
+        <p:spPr>
+          <a:xfrm>
+            <a:off x="1145540" y="827405"/>
+            <a:ext cx="9292590" cy="4739005"/>
+          </a:xfrm>
+          <a:prstGeom prst="rect">
+            <a:avLst/>
+          </a:prstGeom>
+        </p:spPr>
+        <p:txBody>
+          <a:bodyPr wrap="square">
+            <a:spAutoFit/>
+          </a:bodyPr>
+          <a:p>
+            <a:pPr fontAlgn="base">
+              <a:spcBef>
+                <a:spcPct val="0"/>
+              </a:spcBef>
+              <a:spcAft>
+                <a:spcPct val="0"/>
+              </a:spcAft>
+            </a:pPr>
+            <a:r>
+              <a:rPr lang="en-US" altLang="zh-CN" sz="4400" b="1" i="0">
+                <a:solidFill>
+                  <a:srgbClr val="003366"/>
+                </a:solidFill>
+                <a:latin typeface="Cambria" panose="02040503050406030204"/>
+                <a:ea typeface="Cambria" panose="02040503050406030204"/>
+              </a:rPr>
+              <a:t>Conclusiones</a:t>
+            </a:r>
+            <a:endParaRPr lang="en-US" altLang="zh-CN" sz="4400" b="1" i="0">
+              <a:solidFill>
+                <a:srgbClr val="003366"/>
+              </a:solidFill>
+              <a:latin typeface="Cambria" panose="02040503050406030204"/>
+              <a:ea typeface="Cambria" panose="02040503050406030204"/>
+            </a:endParaRPr>
+          </a:p>
+          <a:p>
+            <a:pPr algn="ctr" fontAlgn="base">
+              <a:spcBef>
+                <a:spcPct val="0"/>
+              </a:spcBef>
+              <a:spcAft>
+                <a:spcPct val="0"/>
+              </a:spcAft>
+            </a:pPr>
+            <a:r>
+              <a:rPr lang="en-US" altLang="zh-CN" sz="1600" b="1" i="0">
+                <a:solidFill>
+                  <a:srgbClr val="FFFFFF"/>
+                </a:solidFill>
+                <a:latin typeface="Arial" panose="020B0604020202020204"/>
+                <a:ea typeface="Arial" panose="020B0604020202020204"/>
+              </a:rPr>
+              <a:t>a) Análisis</a:t>
+            </a:r>
+            <a:endParaRPr lang="en-US" altLang="zh-CN" sz="1600" b="1" i="0">
+              <a:solidFill>
+                <a:srgbClr val="FFFFFF"/>
+              </a:solidFill>
+              <a:latin typeface="Arial" panose="020B0604020202020204"/>
+              <a:ea typeface="Arial" panose="020B0604020202020204"/>
+            </a:endParaRPr>
+          </a:p>
+          <a:p>
+            <a:pPr fontAlgn="base">
+              <a:spcBef>
+                <a:spcPct val="0"/>
+              </a:spcBef>
+              <a:spcAft>
+                <a:spcPct val="0"/>
+              </a:spcAft>
+            </a:pPr>
+            <a:r>
+              <a:rPr lang="en-US" altLang="zh-CN" b="0" i="0">
+                <a:solidFill>
+                  <a:srgbClr val="1F2937"/>
+                </a:solidFill>
+                <a:latin typeface="Calibri" panose="020F0502020204030204"/>
+                <a:ea typeface="Calibri" panose="020F0502020204030204"/>
+              </a:rPr>
+              <a:t>87 RFs, 24 RNFs y 67 HUs especificados formalmente, derivados sin invención del Inventario Funcional Maestro.</a:t>
+            </a:r>
+            <a:endParaRPr lang="en-US" altLang="zh-CN" b="0" i="0">
+              <a:solidFill>
+                <a:srgbClr val="1F2937"/>
+              </a:solidFill>
+              <a:latin typeface="Calibri" panose="020F0502020204030204"/>
+              <a:ea typeface="Calibri" panose="020F0502020204030204"/>
+            </a:endParaRPr>
+          </a:p>
+          <a:p>
+            <a:pPr algn="ctr" fontAlgn="base">
+              <a:spcBef>
+                <a:spcPct val="0"/>
+              </a:spcBef>
+              <a:spcAft>
+                <a:spcPct val="0"/>
+              </a:spcAft>
+            </a:pPr>
+            <a:r>
+              <a:rPr lang="en-US" altLang="zh-CN" sz="1600" b="1" i="0">
+                <a:solidFill>
+                  <a:srgbClr val="FFFFFF"/>
+                </a:solidFill>
+                <a:latin typeface="Arial" panose="020B0604020202020204"/>
+                <a:ea typeface="Arial" panose="020B0604020202020204"/>
+              </a:rPr>
+              <a:t>b) Diseño</a:t>
+            </a:r>
+            <a:endParaRPr lang="en-US" altLang="zh-CN" sz="1600" b="1" i="0">
+              <a:solidFill>
+                <a:srgbClr val="FFFFFF"/>
+              </a:solidFill>
+              <a:latin typeface="Arial" panose="020B0604020202020204"/>
+              <a:ea typeface="Arial" panose="020B0604020202020204"/>
+            </a:endParaRPr>
+          </a:p>
+          <a:p>
+            <a:pPr fontAlgn="base">
+              <a:spcBef>
+                <a:spcPct val="0"/>
+              </a:spcBef>
+              <a:spcAft>
+                <a:spcPct val="0"/>
+              </a:spcAft>
+            </a:pPr>
+            <a:r>
+              <a:rPr lang="en-US" altLang="zh-CN" b="0" i="0">
+                <a:solidFill>
+                  <a:srgbClr val="1F2937"/>
+                </a:solidFill>
+                <a:latin typeface="Calibri" panose="020F0502020204030204"/>
+                <a:ea typeface="Calibri" panose="020F0502020204030204"/>
+              </a:rPr>
+              <a:t>Arquitectura Zero Trust + RLS y contrato OpenAPI 3.1 (50 endpoints, 45 esquemas) como fuente de verdad.</a:t>
+            </a:r>
+            <a:endParaRPr lang="en-US" altLang="zh-CN" b="0" i="0">
+              <a:solidFill>
+                <a:srgbClr val="1F2937"/>
+              </a:solidFill>
+              <a:latin typeface="Calibri" panose="020F0502020204030204"/>
+              <a:ea typeface="Calibri" panose="020F0502020204030204"/>
+            </a:endParaRPr>
+          </a:p>
+          <a:p>
+            <a:pPr algn="ctr" fontAlgn="base">
+              <a:spcBef>
+                <a:spcPct val="0"/>
+              </a:spcBef>
+              <a:spcAft>
+                <a:spcPct val="0"/>
+              </a:spcAft>
+            </a:pPr>
+            <a:r>
+              <a:rPr lang="en-US" altLang="zh-CN" sz="1600" b="1" i="0">
+                <a:solidFill>
+                  <a:srgbClr val="FFFFFF"/>
+                </a:solidFill>
+                <a:latin typeface="Arial" panose="020B0604020202020204"/>
+                <a:ea typeface="Arial" panose="020B0604020202020204"/>
+              </a:rPr>
+              <a:t>c) Implementación</a:t>
+            </a:r>
+            <a:endParaRPr lang="en-US" altLang="zh-CN" sz="1600" b="1" i="0">
+              <a:solidFill>
+                <a:srgbClr val="FFFFFF"/>
+              </a:solidFill>
+              <a:latin typeface="Arial" panose="020B0604020202020204"/>
+              <a:ea typeface="Arial" panose="020B0604020202020204"/>
+            </a:endParaRPr>
+          </a:p>
+          <a:p>
+            <a:pPr fontAlgn="base">
+              <a:spcBef>
+                <a:spcPct val="0"/>
+              </a:spcBef>
+              <a:spcAft>
+                <a:spcPct val="0"/>
+              </a:spcAft>
+            </a:pPr>
+            <a:r>
+              <a:rPr lang="en-US" altLang="zh-CN" b="0" i="0">
+                <a:solidFill>
+                  <a:srgbClr val="1F2937"/>
+                </a:solidFill>
+                <a:latin typeface="Calibri" panose="020F0502020204030204"/>
+                <a:ea typeface="Calibri" panose="020F0502020204030204"/>
+              </a:rPr>
+              <a:t>8 sprints Scrum + SDD + XP construyeron un MVP operativo con trazabilidad de código a requisito.</a:t>
+            </a:r>
+            <a:endParaRPr lang="en-US" altLang="zh-CN" b="0" i="0">
+              <a:solidFill>
+                <a:srgbClr val="1F2937"/>
+              </a:solidFill>
+              <a:latin typeface="Calibri" panose="020F0502020204030204"/>
+              <a:ea typeface="Calibri" panose="020F0502020204030204"/>
+            </a:endParaRPr>
+          </a:p>
+          <a:p>
+            <a:pPr algn="ctr" fontAlgn="base">
+              <a:spcBef>
+                <a:spcPct val="0"/>
+              </a:spcBef>
+              <a:spcAft>
+                <a:spcPct val="0"/>
+              </a:spcAft>
+            </a:pPr>
+            <a:r>
+              <a:rPr lang="en-US" altLang="zh-CN" sz="1600" b="1" i="0">
+                <a:solidFill>
+                  <a:srgbClr val="FFFFFF"/>
+                </a:solidFill>
+                <a:latin typeface="Arial" panose="020B0604020202020204"/>
+                <a:ea typeface="Arial" panose="020B0604020202020204"/>
+              </a:rPr>
+              <a:t>d) Funcionamiento</a:t>
+            </a:r>
+            <a:endParaRPr lang="en-US" altLang="zh-CN" sz="1600" b="1" i="0">
+              <a:solidFill>
+                <a:srgbClr val="FFFFFF"/>
+              </a:solidFill>
+              <a:latin typeface="Arial" panose="020B0604020202020204"/>
+              <a:ea typeface="Arial" panose="020B0604020202020204"/>
+            </a:endParaRPr>
+          </a:p>
+          <a:p>
+            <a:pPr fontAlgn="base">
+              <a:spcBef>
+                <a:spcPct val="0"/>
+              </a:spcBef>
+              <a:spcAft>
+                <a:spcPct val="0"/>
+              </a:spcAft>
+            </a:pPr>
+            <a:r>
+              <a:rPr lang="en-US" altLang="zh-CN" b="0" i="0">
+                <a:solidFill>
+                  <a:srgbClr val="1F2937"/>
+                </a:solidFill>
+                <a:latin typeface="Calibri" panose="020F0502020204030204"/>
+                <a:ea typeface="Calibri" panose="020F0502020204030204"/>
+              </a:rPr>
+              <a:t>64 - 78% en promedio de cumplimiento en la Ficha de Análisis Documental SDD, en los 4 módulos críticos.</a:t>
+            </a:r>
+            <a:endParaRPr lang="en-US" altLang="zh-CN" b="0" i="0">
+              <a:solidFill>
+                <a:srgbClr val="1F2937"/>
+              </a:solidFill>
+              <a:latin typeface="Calibri" panose="020F0502020204030204"/>
+              <a:ea typeface="Calibri" panose="020F0502020204030204"/>
+            </a:endParaRPr>
+          </a:p>
+          <a:p>
+            <a:pPr algn="ctr" fontAlgn="base">
+              <a:spcBef>
+                <a:spcPct val="0"/>
+              </a:spcBef>
+              <a:spcAft>
+                <a:spcPct val="0"/>
+              </a:spcAft>
+            </a:pPr>
+            <a:r>
+              <a:rPr lang="en-US" altLang="zh-CN" sz="1600" b="1" i="0">
+                <a:solidFill>
+                  <a:srgbClr val="FFFFFF"/>
+                </a:solidFill>
+                <a:latin typeface="Arial" panose="020B0604020202020204"/>
+                <a:ea typeface="Arial" panose="020B0604020202020204"/>
+              </a:rPr>
+              <a:t>e) Calidad y trazabilidad SDD</a:t>
+            </a:r>
+            <a:endParaRPr lang="en-US" altLang="zh-CN" sz="1600" b="1" i="0">
+              <a:solidFill>
+                <a:srgbClr val="FFFFFF"/>
+              </a:solidFill>
+              <a:latin typeface="Arial" panose="020B0604020202020204"/>
+              <a:ea typeface="Arial" panose="020B0604020202020204"/>
+            </a:endParaRPr>
+          </a:p>
+          <a:p>
+            <a:pPr fontAlgn="base">
+              <a:spcBef>
+                <a:spcPct val="0"/>
+              </a:spcBef>
+              <a:spcAft>
+                <a:spcPct val="0"/>
+              </a:spcAft>
+            </a:pPr>
+            <a:r>
+              <a:rPr lang="en-US" altLang="zh-CN" b="0" i="0">
+                <a:solidFill>
+                  <a:srgbClr val="1F2937"/>
+                </a:solidFill>
+                <a:latin typeface="Calibri" panose="020F0502020204030204"/>
+                <a:ea typeface="Calibri" panose="020F0502020204030204"/>
+              </a:rPr>
+              <a:t>100% de trazabilidad en críticos; 12 brechas identificadas y 100% documentadas como deuda técnica visible.</a:t>
+            </a:r>
+            <a:endParaRPr lang="en-US" altLang="zh-CN" b="0" i="0">
+              <a:solidFill>
+                <a:srgbClr val="1F2937"/>
+              </a:solidFill>
+              <a:latin typeface="Calibri" panose="020F0502020204030204"/>
+              <a:ea typeface="Calibri" panose="020F0502020204030204"/>
+            </a:endParaRPr>
+          </a:p>
+          <a:p>
+            <a:pPr algn="r" fontAlgn="base">
+              <a:spcBef>
+                <a:spcPct val="0"/>
+              </a:spcBef>
+              <a:spcAft>
+                <a:spcPct val="0"/>
+              </a:spcAft>
+            </a:pPr>
+            <a:endParaRPr lang="en-US" altLang="zh-CN" sz="1600" b="0" i="0">
+              <a:solidFill>
+                <a:srgbClr val="6B7280"/>
+              </a:solidFill>
+              <a:latin typeface="Calibri" panose="020F0502020204030204"/>
+              <a:ea typeface="Calibri" panose="020F0502020204030204"/>
+            </a:endParaRPr>
           </a:p>
         </p:txBody>
       </p:sp>

</xml_diff>